<commit_message>
App contada en 6 pasos, guía de exposición y demo actualizada
La app pasa a tema claro con glosario, perfiles de ejemplo y umbral
interactivo. Se añade GUIA_EXPOSICION.md y se actualiza la diapositiva
de la demo.

Co-Authored-By: Claude Opus 5.5 <noreply@anthropic.com>
</commit_message>
<xml_diff>
--- a/presentacion/EduFuture_abandono_escolar.pptx
+++ b/presentacion/EduFuture_abandono_escolar.pptx
@@ -124,14 +124,14 @@
   <p:extLst>
     <p:ext uri="{521415D9-36F7-43E2-AB2F-B90AF26B5E84}">
       <p14:sectionLst xmlns:p14="http://schemas.microsoft.com/office/powerpoint/2010/main">
-        <p14:section name="Introducción" id="{62867be6-bb83-c1c5-f94b-74dc8f927f6c}">
+        <p14:section name="Introducción" id="{fe008688-722b-2034-cc01-fb15a289e060}">
           <p14:sldIdLst>
             <p14:sldId id="256"/>
             <p14:sldId id="257"/>
             <p14:sldId id="258"/>
           </p14:sldIdLst>
         </p14:section>
-        <p14:section name="Exploración y limpieza" id="{bb412918-e4cb-eb16-dcb6-01ab6864e5ec}">
+        <p14:section name="Exploración y limpieza" id="{e2904537-c6de-2d5e-99cd-225fdbcdeaa4}">
           <p14:sldIdLst>
             <p14:sldId id="259"/>
             <p14:sldId id="260"/>
@@ -139,13 +139,13 @@
             <p14:sldId id="262"/>
           </p14:sldIdLst>
         </p14:section>
-        <p14:section name="Ingeniería de características" id="{373b84eb-428d-660d-412a-e982457217aa}">
+        <p14:section name="Ingeniería de características" id="{0e484dbb-d7f6-e226-68e7-a2d229f02c76}">
           <p14:sldIdLst>
             <p14:sldId id="263"/>
             <p14:sldId id="264"/>
           </p14:sldIdLst>
         </p14:section>
-        <p14:section name="Modelo y evaluación" id="{c0fad693-cb62-bf22-1841-542021fad5e6}">
+        <p14:section name="Modelo y evaluación" id="{cc3d9341-b3c5-3273-b2e0-ddbe8933e2f2}">
           <p14:sldIdLst>
             <p14:sldId id="265"/>
             <p14:sldId id="266"/>
@@ -153,7 +153,7 @@
             <p14:sldId id="268"/>
           </p14:sldIdLst>
         </p14:section>
-        <p14:section name="Interpretación y recomendaciones" id="{786de521-2325-cd1a-3fec-c46e7674fa3c}">
+        <p14:section name="Interpretación y recomendaciones" id="{ef9e8264-b921-e4c4-a091-a5f7127ad518}">
           <p14:sldIdLst>
             <p14:sldId id="269"/>
             <p14:sldId id="270"/>
@@ -3917,7 +3917,7 @@
           <a:p>
             <a:r>
               <a:rPr lang="en-US" dirty="0"/>
-              <a:t>Aquí hacemos la demo en vivo. Recomendación: abrir la pestaña de predicción e introducir un perfil de riesgo, por ejemplo asistencia del 65 %, 4 suspensos, nota 4,5 e intención de continuar 1. El modelo devuelve riesgo alto y las señales con su apoyo sugerido.</a:t>
+              <a:t>Demo en vivo (arrancar la app unos minutos antes). Ir a la pestaña 5, Probar con un estudiante. Pulsar el botón Sin señales de riesgo: riesgo bajo. Pulsar Riesgo alto: la flecha pasa a la zona roja y aparecen las señales (asistencia, suspensos, dificultad económica) con el apoyo sugerido para cada una. Si hay tiempo, en la pestaña 4 mover el umbral para enseñar que detectar más abandonos obliga a revisar más casos.</a:t>
             </a:r>
             <a:endParaRPr lang="en-US" dirty="0"/>
           </a:p>
@@ -10282,11 +10282,11 @@
         <p:spPr>
           <a:xfrm>
             <a:off x="548640" y="1737360"/>
-            <a:ext cx="2624328" cy="2926080"/>
+            <a:ext cx="1737360" cy="2926080"/>
           </a:xfrm>
           <a:prstGeom prst="roundRect">
             <a:avLst>
-              <a:gd name="adj" fmla="val 4181"/>
+              <a:gd name="adj" fmla="val 6316"/>
             </a:avLst>
           </a:prstGeom>
           <a:solidFill>
@@ -10297,13 +10297,13 @@
       </p:sp>
       <p:sp>
         <p:nvSpPr>
-          <p:cNvPr id="5" name="Círculo FaChartColumn"/>
+          <p:cNvPr id="5" name="Círculo FaFlag"/>
           <p:cNvSpPr/>
           <p:nvPr/>
         </p:nvSpPr>
         <p:spPr>
           <a:xfrm>
-            <a:off x="1453896" y="1965960"/>
+            <a:off x="1005840" y="1965960"/>
             <a:ext cx="822960" cy="822960"/>
           </a:xfrm>
           <a:prstGeom prst="ellipse">
@@ -10317,7 +10317,7 @@
       </p:sp>
       <p:pic>
         <p:nvPicPr>
-          <p:cNvPr id="6" name="Image 0" descr="FaChartColumn">    </p:cNvPr>
+          <p:cNvPr id="6" name="Image 0" descr="FaFlag">    </p:cNvPr>
           <p:cNvPicPr>
             <a:picLocks noChangeAspect="1"/>
           </p:cNvPicPr>
@@ -10331,7 +10331,7 @@
         </p:blipFill>
         <p:spPr>
           <a:xfrm>
-            <a:off x="1676095" y="2188159"/>
+            <a:off x="1228039" y="2188159"/>
             <a:ext cx="378562" cy="378562"/>
           </a:xfrm>
           <a:prstGeom prst="rect">
@@ -10347,8 +10347,8 @@
         </p:nvSpPr>
         <p:spPr>
           <a:xfrm>
-            <a:off x="685800" y="2926080"/>
-            <a:ext cx="2350008" cy="457200"/>
+            <a:off x="640080" y="2926080"/>
+            <a:ext cx="1554480" cy="457200"/>
           </a:xfrm>
           <a:prstGeom prst="rect">
             <a:avLst/>
@@ -10364,14 +10364,14 @@
               <a:buNone/>
             </a:pPr>
             <a:r>
-              <a:rPr lang="en-US" sz="1700" b="1" dirty="0">
+              <a:rPr lang="en-US" sz="1600" b="1" dirty="0">
                 <a:solidFill>
                   <a:schemeClr val="tx1"/>
                 </a:solidFill>
               </a:rPr>
-              <a:t>Exploración</a:t>
-            </a:r>
-            <a:endParaRPr lang="en-US" sz="1700" dirty="0"/>
+              <a:t>1 · El reto</a:t>
+            </a:r>
+            <a:endParaRPr lang="en-US" sz="1600" dirty="0"/>
           </a:p>
         </p:txBody>
       </p:sp>
@@ -10383,8 +10383,8 @@
         </p:nvSpPr>
         <p:spPr>
           <a:xfrm>
-            <a:off x="731520" y="3429000"/>
-            <a:ext cx="2258568" cy="1097280"/>
+            <a:off x="658368" y="3429000"/>
+            <a:ext cx="1517904" cy="1097280"/>
           </a:xfrm>
           <a:prstGeom prst="rect">
             <a:avLst/>
@@ -10405,7 +10405,7 @@
                   <a:schemeClr val="tx2"/>
                 </a:solidFill>
               </a:rPr>
-              <a:t>Indicadores y tasa de abandono por grupo</a:t>
+              <a:t>Problema y objetivo</a:t>
             </a:r>
             <a:endParaRPr lang="en-US" sz="1400" dirty="0"/>
           </a:p>
@@ -10419,12 +10419,12 @@
         </p:nvSpPr>
         <p:spPr>
           <a:xfrm>
-            <a:off x="3355848" y="1737360"/>
-            <a:ext cx="2624328" cy="2926080"/>
+            <a:off x="2414016" y="1737360"/>
+            <a:ext cx="1737360" cy="2926080"/>
           </a:xfrm>
           <a:prstGeom prst="roundRect">
             <a:avLst>
-              <a:gd name="adj" fmla="val 4181"/>
+              <a:gd name="adj" fmla="val 6316"/>
             </a:avLst>
           </a:prstGeom>
           <a:solidFill>
@@ -10435,13 +10435,13 @@
       </p:sp>
       <p:sp>
         <p:nvSpPr>
-          <p:cNvPr id="10" name="Círculo FaGears"/>
+          <p:cNvPr id="10" name="Círculo FaChartColumn"/>
           <p:cNvSpPr/>
           <p:nvPr/>
         </p:nvSpPr>
         <p:spPr>
           <a:xfrm>
-            <a:off x="4261104" y="1965960"/>
+            <a:off x="2871216" y="1965960"/>
             <a:ext cx="822960" cy="822960"/>
           </a:xfrm>
           <a:prstGeom prst="ellipse">
@@ -10455,7 +10455,7 @@
       </p:sp>
       <p:pic>
         <p:nvPicPr>
-          <p:cNvPr id="11" name="Image 1" descr="FaGears">    </p:cNvPr>
+          <p:cNvPr id="11" name="Image 1" descr="FaChartColumn">    </p:cNvPr>
           <p:cNvPicPr>
             <a:picLocks noChangeAspect="1"/>
           </p:cNvPicPr>
@@ -10469,7 +10469,7 @@
         </p:blipFill>
         <p:spPr>
           <a:xfrm>
-            <a:off x="4483303" y="2188159"/>
+            <a:off x="3093415" y="2188159"/>
             <a:ext cx="378562" cy="378562"/>
           </a:xfrm>
           <a:prstGeom prst="rect">
@@ -10485,8 +10485,8 @@
         </p:nvSpPr>
         <p:spPr>
           <a:xfrm>
-            <a:off x="3493008" y="2926080"/>
-            <a:ext cx="2350008" cy="457200"/>
+            <a:off x="2505456" y="2926080"/>
+            <a:ext cx="1554480" cy="457200"/>
           </a:xfrm>
           <a:prstGeom prst="rect">
             <a:avLst/>
@@ -10502,14 +10502,14 @@
               <a:buNone/>
             </a:pPr>
             <a:r>
-              <a:rPr lang="en-US" sz="1700" b="1" dirty="0">
+              <a:rPr lang="en-US" sz="1600" b="1" dirty="0">
                 <a:solidFill>
                   <a:schemeClr val="tx1"/>
                 </a:solidFill>
               </a:rPr>
-              <a:t>Modelo</a:t>
-            </a:r>
-            <a:endParaRPr lang="en-US" sz="1700" dirty="0"/>
+              <a:t>2 · Los datos</a:t>
+            </a:r>
+            <a:endParaRPr lang="en-US" sz="1600" dirty="0"/>
           </a:p>
         </p:txBody>
       </p:sp>
@@ -10521,8 +10521,8 @@
         </p:nvSpPr>
         <p:spPr>
           <a:xfrm>
-            <a:off x="3538728" y="3429000"/>
-            <a:ext cx="2258568" cy="1097280"/>
+            <a:off x="2523744" y="3429000"/>
+            <a:ext cx="1517904" cy="1097280"/>
           </a:xfrm>
           <a:prstGeom prst="rect">
             <a:avLst/>
@@ -10543,7 +10543,7 @@
                   <a:schemeClr val="tx2"/>
                 </a:solidFill>
               </a:rPr>
-              <a:t>Métricas, matriz de confusión, coeficientes y equidad</a:t>
+              <a:t>Las señales del abandono</a:t>
             </a:r>
             <a:endParaRPr lang="en-US" sz="1400" dirty="0"/>
           </a:p>
@@ -10557,12 +10557,12 @@
         </p:nvSpPr>
         <p:spPr>
           <a:xfrm>
-            <a:off x="6163056" y="1737360"/>
-            <a:ext cx="2624328" cy="2926080"/>
+            <a:off x="4279392" y="1737360"/>
+            <a:ext cx="1737360" cy="2926080"/>
           </a:xfrm>
           <a:prstGeom prst="roundRect">
             <a:avLst>
-              <a:gd name="adj" fmla="val 4181"/>
+              <a:gd name="adj" fmla="val 6316"/>
             </a:avLst>
           </a:prstGeom>
           <a:solidFill>
@@ -10573,27 +10573,27 @@
       </p:sp>
       <p:sp>
         <p:nvSpPr>
-          <p:cNvPr id="15" name="Círculo FaUserCheck"/>
+          <p:cNvPr id="15" name="Círculo FaGears"/>
           <p:cNvSpPr/>
           <p:nvPr/>
         </p:nvSpPr>
         <p:spPr>
           <a:xfrm>
-            <a:off x="7068312" y="1965960"/>
+            <a:off x="4736592" y="1965960"/>
             <a:ext cx="822960" cy="822960"/>
           </a:xfrm>
           <a:prstGeom prst="ellipse">
             <a:avLst/>
           </a:prstGeom>
           <a:solidFill>
-            <a:schemeClr val="accent1"/>
+            <a:schemeClr val="tx1"/>
           </a:solidFill>
           <a:ln/>
         </p:spPr>
       </p:sp>
       <p:pic>
         <p:nvPicPr>
-          <p:cNvPr id="16" name="Image 2" descr="FaUserCheck">    </p:cNvPr>
+          <p:cNvPr id="16" name="Image 2" descr="FaGears">    </p:cNvPr>
           <p:cNvPicPr>
             <a:picLocks noChangeAspect="1"/>
           </p:cNvPicPr>
@@ -10607,7 +10607,7 @@
         </p:blipFill>
         <p:spPr>
           <a:xfrm>
-            <a:off x="7290511" y="2188159"/>
+            <a:off x="4958791" y="2188159"/>
             <a:ext cx="378562" cy="378562"/>
           </a:xfrm>
           <a:prstGeom prst="rect">
@@ -10623,8 +10623,8 @@
         </p:nvSpPr>
         <p:spPr>
           <a:xfrm>
-            <a:off x="6300216" y="2926080"/>
-            <a:ext cx="2350008" cy="457200"/>
+            <a:off x="4370832" y="2926080"/>
+            <a:ext cx="1554480" cy="457200"/>
           </a:xfrm>
           <a:prstGeom prst="rect">
             <a:avLst/>
@@ -10640,14 +10640,14 @@
               <a:buNone/>
             </a:pPr>
             <a:r>
-              <a:rPr lang="en-US" sz="1700" b="1" dirty="0">
+              <a:rPr lang="en-US" sz="1600" b="1" dirty="0">
                 <a:solidFill>
                   <a:schemeClr val="tx1"/>
                 </a:solidFill>
               </a:rPr>
-              <a:t>Predicción individual</a:t>
-            </a:r>
-            <a:endParaRPr lang="en-US" sz="1700" dirty="0"/>
+              <a:t>3 · El modelo</a:t>
+            </a:r>
+            <a:endParaRPr lang="en-US" sz="1600" dirty="0"/>
           </a:p>
         </p:txBody>
       </p:sp>
@@ -10659,8 +10659,8 @@
         </p:nvSpPr>
         <p:spPr>
           <a:xfrm>
-            <a:off x="6345936" y="3429000"/>
-            <a:ext cx="2258568" cy="1097280"/>
+            <a:off x="4389120" y="3429000"/>
+            <a:ext cx="1517904" cy="1097280"/>
           </a:xfrm>
           <a:prstGeom prst="rect">
             <a:avLst/>
@@ -10681,7 +10681,7 @@
                   <a:schemeClr val="tx2"/>
                 </a:solidFill>
               </a:rPr>
-              <a:t>Probabilidad de riesgo, señales y apoyo sugerido</a:t>
+              <a:t>Cómo funciona y qué pesa</a:t>
             </a:r>
             <a:endParaRPr lang="en-US" sz="1400" dirty="0"/>
           </a:p>
@@ -10695,12 +10695,12 @@
         </p:nvSpPr>
         <p:spPr>
           <a:xfrm>
-            <a:off x="8970264" y="1737360"/>
-            <a:ext cx="2624328" cy="2926080"/>
+            <a:off x="6144768" y="1737360"/>
+            <a:ext cx="1737360" cy="2926080"/>
           </a:xfrm>
           <a:prstGeom prst="roundRect">
             <a:avLst>
-              <a:gd name="adj" fmla="val 4181"/>
+              <a:gd name="adj" fmla="val 6316"/>
             </a:avLst>
           </a:prstGeom>
           <a:solidFill>
@@ -10711,13 +10711,13 @@
       </p:sp>
       <p:sp>
         <p:nvSpPr>
-          <p:cNvPr id="20" name="Círculo FaScaleBalanced"/>
+          <p:cNvPr id="20" name="Círculo FaBullseye"/>
           <p:cNvSpPr/>
           <p:nvPr/>
         </p:nvSpPr>
         <p:spPr>
           <a:xfrm>
-            <a:off x="9875520" y="1965960"/>
+            <a:off x="6601968" y="1965960"/>
             <a:ext cx="822960" cy="822960"/>
           </a:xfrm>
           <a:prstGeom prst="ellipse">
@@ -10731,7 +10731,7 @@
       </p:sp>
       <p:pic>
         <p:nvPicPr>
-          <p:cNvPr id="21" name="Image 3" descr="FaScaleBalanced">    </p:cNvPr>
+          <p:cNvPr id="21" name="Image 3" descr="FaBullseye">    </p:cNvPr>
           <p:cNvPicPr>
             <a:picLocks noChangeAspect="1"/>
           </p:cNvPicPr>
@@ -10745,7 +10745,7 @@
         </p:blipFill>
         <p:spPr>
           <a:xfrm>
-            <a:off x="10097719" y="2188159"/>
+            <a:off x="6824167" y="2188159"/>
             <a:ext cx="378562" cy="378562"/>
           </a:xfrm>
           <a:prstGeom prst="rect">
@@ -10761,8 +10761,8 @@
         </p:nvSpPr>
         <p:spPr>
           <a:xfrm>
-            <a:off x="9107424" y="2926080"/>
-            <a:ext cx="2350008" cy="457200"/>
+            <a:off x="6236208" y="2926080"/>
+            <a:ext cx="1554480" cy="457200"/>
           </a:xfrm>
           <a:prstGeom prst="rect">
             <a:avLst/>
@@ -10778,14 +10778,14 @@
               <a:buNone/>
             </a:pPr>
             <a:r>
-              <a:rPr lang="en-US" sz="1700" b="1" dirty="0">
+              <a:rPr lang="en-US" sz="1600" b="1" dirty="0">
                 <a:solidFill>
                   <a:schemeClr val="tx1"/>
                 </a:solidFill>
               </a:rPr>
-              <a:t>Uso responsable</a:t>
-            </a:r>
-            <a:endParaRPr lang="en-US" sz="1700" dirty="0"/>
+              <a:t>4 · ¿Acierta?</a:t>
+            </a:r>
+            <a:endParaRPr lang="en-US" sz="1600" dirty="0"/>
           </a:p>
         </p:txBody>
       </p:sp>
@@ -10797,8 +10797,8 @@
         </p:nvSpPr>
         <p:spPr>
           <a:xfrm>
-            <a:off x="9153144" y="3429000"/>
-            <a:ext cx="2258568" cy="1097280"/>
+            <a:off x="6254496" y="3429000"/>
+            <a:ext cx="1517904" cy="1097280"/>
           </a:xfrm>
           <a:prstGeom prst="rect">
             <a:avLst/>
@@ -10819,7 +10819,7 @@
                   <a:schemeClr val="tx2"/>
                 </a:solidFill>
               </a:rPr>
-              <a:t>Qué hace y qué no hace el modelo</a:t>
+              <a:t>Métricas y umbral interactivo</a:t>
             </a:r>
             <a:endParaRPr lang="en-US" sz="1400" dirty="0"/>
           </a:p>
@@ -10827,36 +10827,36 @@
       </p:sp>
       <p:sp>
         <p:nvSpPr>
-          <p:cNvPr id="24" name="Comando"/>
+          <p:cNvPr id="24" name="Tarjeta"/>
           <p:cNvSpPr/>
           <p:nvPr/>
         </p:nvSpPr>
         <p:spPr>
           <a:xfrm>
-            <a:off x="548640" y="4937760"/>
-            <a:ext cx="11064240" cy="1234440"/>
+            <a:off x="8010144" y="1737360"/>
+            <a:ext cx="1737360" cy="2926080"/>
           </a:xfrm>
           <a:prstGeom prst="roundRect">
             <a:avLst>
-              <a:gd name="adj" fmla="val 8889"/>
+              <a:gd name="adj" fmla="val 6316"/>
             </a:avLst>
           </a:prstGeom>
           <a:solidFill>
-            <a:schemeClr val="tx1"/>
+            <a:schemeClr val="bg2"/>
           </a:solidFill>
           <a:ln/>
         </p:spPr>
       </p:sp>
       <p:sp>
         <p:nvSpPr>
-          <p:cNvPr id="25" name="Círculo FaLaptopCode"/>
+          <p:cNvPr id="25" name="Círculo FaUserCheck"/>
           <p:cNvSpPr/>
           <p:nvPr/>
         </p:nvSpPr>
         <p:spPr>
           <a:xfrm>
-            <a:off x="777240" y="5184648"/>
-            <a:ext cx="731520" cy="731520"/>
+            <a:off x="8467344" y="1965960"/>
+            <a:ext cx="822960" cy="822960"/>
           </a:xfrm>
           <a:prstGeom prst="ellipse">
             <a:avLst/>
@@ -10869,7 +10869,7 @@
       </p:sp>
       <p:pic>
         <p:nvPicPr>
-          <p:cNvPr id="26" name="Image 4" descr="FaLaptopCode">    </p:cNvPr>
+          <p:cNvPr id="26" name="Image 4" descr="FaUserCheck">    </p:cNvPr>
           <p:cNvPicPr>
             <a:picLocks noChangeAspect="1"/>
           </p:cNvPicPr>
@@ -10883,6 +10883,282 @@
         </p:blipFill>
         <p:spPr>
           <a:xfrm>
+            <a:off x="8689543" y="2188159"/>
+            <a:ext cx="378562" cy="378562"/>
+          </a:xfrm>
+          <a:prstGeom prst="rect">
+            <a:avLst/>
+          </a:prstGeom>
+        </p:spPr>
+      </p:pic>
+      <p:sp>
+        <p:nvSpPr>
+          <p:cNvPr id="27" name="Text 20"/>
+          <p:cNvSpPr txBox="1"/>
+          <p:nvPr/>
+        </p:nvSpPr>
+        <p:spPr>
+          <a:xfrm>
+            <a:off x="8101584" y="2926080"/>
+            <a:ext cx="1554480" cy="457200"/>
+          </a:xfrm>
+          <a:prstGeom prst="rect">
+            <a:avLst/>
+          </a:prstGeom>
+          <a:noFill/>
+          <a:ln/>
+        </p:spPr>
+        <p:txBody>
+          <a:bodyPr wrap="square" lIns="0" tIns="0" rIns="0" bIns="0" rtlCol="0" anchor="ctr"/>
+          <a:lstStyle/>
+          <a:p>
+            <a:pPr algn="ctr" indent="0" marL="0">
+              <a:buNone/>
+            </a:pPr>
+            <a:r>
+              <a:rPr lang="en-US" sz="1600" b="1" dirty="0">
+                <a:solidFill>
+                  <a:schemeClr val="tx1"/>
+                </a:solidFill>
+              </a:rPr>
+              <a:t>5 · Probar</a:t>
+            </a:r>
+            <a:endParaRPr lang="en-US" sz="1600" dirty="0"/>
+          </a:p>
+        </p:txBody>
+      </p:sp>
+      <p:sp>
+        <p:nvSpPr>
+          <p:cNvPr id="28" name="Text 21"/>
+          <p:cNvSpPr txBox="1"/>
+          <p:nvPr/>
+        </p:nvSpPr>
+        <p:spPr>
+          <a:xfrm>
+            <a:off x="8119872" y="3429000"/>
+            <a:ext cx="1517904" cy="1097280"/>
+          </a:xfrm>
+          <a:prstGeom prst="rect">
+            <a:avLst/>
+          </a:prstGeom>
+          <a:noFill/>
+          <a:ln/>
+        </p:spPr>
+        <p:txBody>
+          <a:bodyPr wrap="square" lIns="0" tIns="0" rIns="0" bIns="0" rtlCol="0" anchor="t"/>
+          <a:lstStyle/>
+          <a:p>
+            <a:pPr algn="ctr" indent="0" marL="0">
+              <a:buNone/>
+            </a:pPr>
+            <a:r>
+              <a:rPr lang="en-US" sz="1400" dirty="0">
+                <a:solidFill>
+                  <a:schemeClr val="tx2"/>
+                </a:solidFill>
+              </a:rPr>
+              <a:t>Ejemplos y apoyo sugerido</a:t>
+            </a:r>
+            <a:endParaRPr lang="en-US" sz="1400" dirty="0"/>
+          </a:p>
+        </p:txBody>
+      </p:sp>
+      <p:sp>
+        <p:nvSpPr>
+          <p:cNvPr id="29" name="Tarjeta"/>
+          <p:cNvSpPr/>
+          <p:nvPr/>
+        </p:nvSpPr>
+        <p:spPr>
+          <a:xfrm>
+            <a:off x="9875520" y="1737360"/>
+            <a:ext cx="1737360" cy="2926080"/>
+          </a:xfrm>
+          <a:prstGeom prst="roundRect">
+            <a:avLst>
+              <a:gd name="adj" fmla="val 6316"/>
+            </a:avLst>
+          </a:prstGeom>
+          <a:solidFill>
+            <a:schemeClr val="bg2"/>
+          </a:solidFill>
+          <a:ln/>
+        </p:spPr>
+      </p:sp>
+      <p:sp>
+        <p:nvSpPr>
+          <p:cNvPr id="30" name="Círculo FaLightbulb"/>
+          <p:cNvSpPr/>
+          <p:nvPr/>
+        </p:nvSpPr>
+        <p:spPr>
+          <a:xfrm>
+            <a:off x="10332720" y="1965960"/>
+            <a:ext cx="822960" cy="822960"/>
+          </a:xfrm>
+          <a:prstGeom prst="ellipse">
+            <a:avLst/>
+          </a:prstGeom>
+          <a:solidFill>
+            <a:schemeClr val="tx1"/>
+          </a:solidFill>
+          <a:ln/>
+        </p:spPr>
+      </p:sp>
+      <p:pic>
+        <p:nvPicPr>
+          <p:cNvPr id="31" name="Image 5" descr="FaLightbulb">    </p:cNvPr>
+          <p:cNvPicPr>
+            <a:picLocks noChangeAspect="1"/>
+          </p:cNvPicPr>
+          <p:nvPr/>
+        </p:nvPicPr>
+        <p:blipFill>
+          <a:blip r:embed="rId6"/>
+          <a:stretch>
+            <a:fillRect/>
+          </a:stretch>
+        </p:blipFill>
+        <p:spPr>
+          <a:xfrm>
+            <a:off x="10554919" y="2188159"/>
+            <a:ext cx="378562" cy="378562"/>
+          </a:xfrm>
+          <a:prstGeom prst="rect">
+            <a:avLst/>
+          </a:prstGeom>
+        </p:spPr>
+      </p:pic>
+      <p:sp>
+        <p:nvSpPr>
+          <p:cNvPr id="32" name="Text 24"/>
+          <p:cNvSpPr txBox="1"/>
+          <p:nvPr/>
+        </p:nvSpPr>
+        <p:spPr>
+          <a:xfrm>
+            <a:off x="9966960" y="2926080"/>
+            <a:ext cx="1554480" cy="457200"/>
+          </a:xfrm>
+          <a:prstGeom prst="rect">
+            <a:avLst/>
+          </a:prstGeom>
+          <a:noFill/>
+          <a:ln/>
+        </p:spPr>
+        <p:txBody>
+          <a:bodyPr wrap="square" lIns="0" tIns="0" rIns="0" bIns="0" rtlCol="0" anchor="ctr"/>
+          <a:lstStyle/>
+          <a:p>
+            <a:pPr algn="ctr" indent="0" marL="0">
+              <a:buNone/>
+            </a:pPr>
+            <a:r>
+              <a:rPr lang="en-US" sz="1600" b="1" dirty="0">
+                <a:solidFill>
+                  <a:schemeClr val="tx1"/>
+                </a:solidFill>
+              </a:rPr>
+              <a:t>6 · Acciones</a:t>
+            </a:r>
+            <a:endParaRPr lang="en-US" sz="1600" dirty="0"/>
+          </a:p>
+        </p:txBody>
+      </p:sp>
+      <p:sp>
+        <p:nvSpPr>
+          <p:cNvPr id="33" name="Text 25"/>
+          <p:cNvSpPr txBox="1"/>
+          <p:nvPr/>
+        </p:nvSpPr>
+        <p:spPr>
+          <a:xfrm>
+            <a:off x="9985248" y="3429000"/>
+            <a:ext cx="1517904" cy="1097280"/>
+          </a:xfrm>
+          <a:prstGeom prst="rect">
+            <a:avLst/>
+          </a:prstGeom>
+          <a:noFill/>
+          <a:ln/>
+        </p:spPr>
+        <p:txBody>
+          <a:bodyPr wrap="square" lIns="0" tIns="0" rIns="0" bIns="0" rtlCol="0" anchor="t"/>
+          <a:lstStyle/>
+          <a:p>
+            <a:pPr algn="ctr" indent="0" marL="0">
+              <a:buNone/>
+            </a:pPr>
+            <a:r>
+              <a:rPr lang="en-US" sz="1400" dirty="0">
+                <a:solidFill>
+                  <a:schemeClr val="tx2"/>
+                </a:solidFill>
+              </a:rPr>
+              <a:t>Recomendaciones y uso responsable</a:t>
+            </a:r>
+            <a:endParaRPr lang="en-US" sz="1400" dirty="0"/>
+          </a:p>
+        </p:txBody>
+      </p:sp>
+      <p:sp>
+        <p:nvSpPr>
+          <p:cNvPr id="34" name="Comando"/>
+          <p:cNvSpPr/>
+          <p:nvPr/>
+        </p:nvSpPr>
+        <p:spPr>
+          <a:xfrm>
+            <a:off x="548640" y="4937760"/>
+            <a:ext cx="11064240" cy="1234440"/>
+          </a:xfrm>
+          <a:prstGeom prst="roundRect">
+            <a:avLst>
+              <a:gd name="adj" fmla="val 8889"/>
+            </a:avLst>
+          </a:prstGeom>
+          <a:solidFill>
+            <a:schemeClr val="tx1"/>
+          </a:solidFill>
+          <a:ln/>
+        </p:spPr>
+      </p:sp>
+      <p:sp>
+        <p:nvSpPr>
+          <p:cNvPr id="35" name="Círculo FaLaptopCode"/>
+          <p:cNvSpPr/>
+          <p:nvPr/>
+        </p:nvSpPr>
+        <p:spPr>
+          <a:xfrm>
+            <a:off x="777240" y="5184648"/>
+            <a:ext cx="731520" cy="731520"/>
+          </a:xfrm>
+          <a:prstGeom prst="ellipse">
+            <a:avLst/>
+          </a:prstGeom>
+          <a:solidFill>
+            <a:schemeClr val="accent1"/>
+          </a:solidFill>
+          <a:ln/>
+        </p:spPr>
+      </p:sp>
+      <p:pic>
+        <p:nvPicPr>
+          <p:cNvPr id="36" name="Image 6" descr="FaLaptopCode">    </p:cNvPr>
+          <p:cNvPicPr>
+            <a:picLocks noChangeAspect="1"/>
+          </p:cNvPicPr>
+          <p:nvPr/>
+        </p:nvPicPr>
+        <p:blipFill>
+          <a:blip r:embed="rId7"/>
+          <a:stretch>
+            <a:fillRect/>
+          </a:stretch>
+        </p:blipFill>
+        <p:spPr>
+          <a:xfrm>
             <a:off x="974750" y="5382158"/>
             <a:ext cx="336499" cy="336499"/>
           </a:xfrm>
@@ -10893,7 +11169,7 @@
       </p:pic>
       <p:sp>
         <p:nvSpPr>
-          <p:cNvPr id="27" name="Text 20"/>
+          <p:cNvPr id="37" name="Text 28"/>
           <p:cNvSpPr txBox="1"/>
           <p:nvPr/>
         </p:nvSpPr>
@@ -10938,7 +11214,7 @@
                   <a:schemeClr val="bg2"/>
                 </a:solidFill>
               </a:rPr>
-              <a:t>Entrena el mismo modelo del notebook y lo pone al alcance del equipo de tutoría.</a:t>
+              <a:t>Cuenta el proyecto en 6 pasos y deja probar el modelo con estudiantes de ejemplo.</a:t>
             </a:r>
             <a:endParaRPr lang="en-US" sz="2000" dirty="0"/>
           </a:p>

</xml_diff>

<commit_message>
Quita el simulador de la app y ajusta demo, guía y README
Co-Authored-By: Claude Opus 5.5 <noreply@anthropic.com>
</commit_message>
<xml_diff>
--- a/presentacion/EduFuture_abandono_escolar.pptx
+++ b/presentacion/EduFuture_abandono_escolar.pptx
@@ -124,14 +124,14 @@
   <p:extLst>
     <p:ext uri="{521415D9-36F7-43E2-AB2F-B90AF26B5E84}">
       <p14:sectionLst xmlns:p14="http://schemas.microsoft.com/office/powerpoint/2010/main">
-        <p14:section name="Introducción" id="{fe008688-722b-2034-cc01-fb15a289e060}">
+        <p14:section name="Introducción" id="{cbc38e3c-e366-ede0-4186-f099a0bbae10}">
           <p14:sldIdLst>
             <p14:sldId id="256"/>
             <p14:sldId id="257"/>
             <p14:sldId id="258"/>
           </p14:sldIdLst>
         </p14:section>
-        <p14:section name="Exploración y limpieza" id="{e2904537-c6de-2d5e-99cd-225fdbcdeaa4}">
+        <p14:section name="Exploración y limpieza" id="{21b413ee-972c-e77f-019e-ac17a0cced0b}">
           <p14:sldIdLst>
             <p14:sldId id="259"/>
             <p14:sldId id="260"/>
@@ -139,13 +139,13 @@
             <p14:sldId id="262"/>
           </p14:sldIdLst>
         </p14:section>
-        <p14:section name="Ingeniería de características" id="{0e484dbb-d7f6-e226-68e7-a2d229f02c76}">
+        <p14:section name="Ingeniería de características" id="{a81815db-d155-3067-f6fb-5b8f7927ab68}">
           <p14:sldIdLst>
             <p14:sldId id="263"/>
             <p14:sldId id="264"/>
           </p14:sldIdLst>
         </p14:section>
-        <p14:section name="Modelo y evaluación" id="{cc3d9341-b3c5-3273-b2e0-ddbe8933e2f2}">
+        <p14:section name="Modelo y evaluación" id="{e98358ed-c9eb-d610-c997-d30bace13d7b}">
           <p14:sldIdLst>
             <p14:sldId id="265"/>
             <p14:sldId id="266"/>
@@ -153,7 +153,7 @@
             <p14:sldId id="268"/>
           </p14:sldIdLst>
         </p14:section>
-        <p14:section name="Interpretación y recomendaciones" id="{ef9e8264-b921-e4c4-a091-a5f7127ad518}">
+        <p14:section name="Interpretación y recomendaciones" id="{c51f7457-e40e-d8af-d55c-d8526c3257d9}">
           <p14:sldIdLst>
             <p14:sldId id="269"/>
             <p14:sldId id="270"/>
@@ -3917,7 +3917,7 @@
           <a:p>
             <a:r>
               <a:rPr lang="en-US" dirty="0"/>
-              <a:t>Demo en vivo (arrancar la app unos minutos antes). Ir a la pestaña 5, Probar con un estudiante. Pulsar el botón Sin señales de riesgo: riesgo bajo. Pulsar Riesgo alto: la flecha pasa a la zona roja y aparecen las señales (asistencia, suspensos, dificultad económica) con el apoyo sugerido para cada una. Si hay tiempo, en la pestaña 4 mover el umbral para enseñar que detectar más abandonos obliga a revisar más casos.</a:t>
+              <a:t>Demo en vivo (arrancar la app unos minutos antes). Pestaña 2: enseñar el gráfico de asistencia, donde el abandono pasa del 3 % al 70 %. Pestaña 4: mover el umbral de 0,50 a 0,35 para enseñar que detectar más abandonos obliga a revisar a más estudiantes, y volver a 0,50. Pestaña 5: el modelo dice a quién ayudar y las recomendaciones dicen cómo.</a:t>
             </a:r>
             <a:endParaRPr lang="en-US" dirty="0"/>
           </a:p>
@@ -10282,11 +10282,11 @@
         <p:spPr>
           <a:xfrm>
             <a:off x="548640" y="1737360"/>
-            <a:ext cx="1737360" cy="2926080"/>
+            <a:ext cx="2066544" cy="2926080"/>
           </a:xfrm>
           <a:prstGeom prst="roundRect">
             <a:avLst>
-              <a:gd name="adj" fmla="val 6316"/>
+              <a:gd name="adj" fmla="val 5310"/>
             </a:avLst>
           </a:prstGeom>
           <a:solidFill>
@@ -10303,7 +10303,7 @@
         </p:nvSpPr>
         <p:spPr>
           <a:xfrm>
-            <a:off x="1005840" y="1965960"/>
+            <a:off x="1170432" y="1965960"/>
             <a:ext cx="822960" cy="822960"/>
           </a:xfrm>
           <a:prstGeom prst="ellipse">
@@ -10331,7 +10331,7 @@
         </p:blipFill>
         <p:spPr>
           <a:xfrm>
-            <a:off x="1228039" y="2188159"/>
+            <a:off x="1392631" y="2188159"/>
             <a:ext cx="378562" cy="378562"/>
           </a:xfrm>
           <a:prstGeom prst="rect">
@@ -10348,7 +10348,7 @@
         <p:spPr>
           <a:xfrm>
             <a:off x="640080" y="2926080"/>
-            <a:ext cx="1554480" cy="457200"/>
+            <a:ext cx="1883664" cy="457200"/>
           </a:xfrm>
           <a:prstGeom prst="rect">
             <a:avLst/>
@@ -10383,8 +10383,8 @@
         </p:nvSpPr>
         <p:spPr>
           <a:xfrm>
-            <a:off x="658368" y="3429000"/>
-            <a:ext cx="1517904" cy="1097280"/>
+            <a:off x="685800" y="3429000"/>
+            <a:ext cx="1792224" cy="1097280"/>
           </a:xfrm>
           <a:prstGeom prst="rect">
             <a:avLst/>
@@ -10419,12 +10419,12 @@
         </p:nvSpPr>
         <p:spPr>
           <a:xfrm>
-            <a:off x="2414016" y="1737360"/>
-            <a:ext cx="1737360" cy="2926080"/>
+            <a:off x="2798064" y="1737360"/>
+            <a:ext cx="2066544" cy="2926080"/>
           </a:xfrm>
           <a:prstGeom prst="roundRect">
             <a:avLst>
-              <a:gd name="adj" fmla="val 6316"/>
+              <a:gd name="adj" fmla="val 5310"/>
             </a:avLst>
           </a:prstGeom>
           <a:solidFill>
@@ -10441,7 +10441,7 @@
         </p:nvSpPr>
         <p:spPr>
           <a:xfrm>
-            <a:off x="2871216" y="1965960"/>
+            <a:off x="3419856" y="1965960"/>
             <a:ext cx="822960" cy="822960"/>
           </a:xfrm>
           <a:prstGeom prst="ellipse">
@@ -10469,7 +10469,7 @@
         </p:blipFill>
         <p:spPr>
           <a:xfrm>
-            <a:off x="3093415" y="2188159"/>
+            <a:off x="3642055" y="2188159"/>
             <a:ext cx="378562" cy="378562"/>
           </a:xfrm>
           <a:prstGeom prst="rect">
@@ -10485,8 +10485,8 @@
         </p:nvSpPr>
         <p:spPr>
           <a:xfrm>
-            <a:off x="2505456" y="2926080"/>
-            <a:ext cx="1554480" cy="457200"/>
+            <a:off x="2889504" y="2926080"/>
+            <a:ext cx="1883664" cy="457200"/>
           </a:xfrm>
           <a:prstGeom prst="rect">
             <a:avLst/>
@@ -10521,8 +10521,8 @@
         </p:nvSpPr>
         <p:spPr>
           <a:xfrm>
-            <a:off x="2523744" y="3429000"/>
-            <a:ext cx="1517904" cy="1097280"/>
+            <a:off x="2935224" y="3429000"/>
+            <a:ext cx="1792224" cy="1097280"/>
           </a:xfrm>
           <a:prstGeom prst="rect">
             <a:avLst/>
@@ -10557,12 +10557,12 @@
         </p:nvSpPr>
         <p:spPr>
           <a:xfrm>
-            <a:off x="4279392" y="1737360"/>
-            <a:ext cx="1737360" cy="2926080"/>
+            <a:off x="5047488" y="1737360"/>
+            <a:ext cx="2066544" cy="2926080"/>
           </a:xfrm>
           <a:prstGeom prst="roundRect">
             <a:avLst>
-              <a:gd name="adj" fmla="val 6316"/>
+              <a:gd name="adj" fmla="val 5310"/>
             </a:avLst>
           </a:prstGeom>
           <a:solidFill>
@@ -10579,7 +10579,7 @@
         </p:nvSpPr>
         <p:spPr>
           <a:xfrm>
-            <a:off x="4736592" y="1965960"/>
+            <a:off x="5669280" y="1965960"/>
             <a:ext cx="822960" cy="822960"/>
           </a:xfrm>
           <a:prstGeom prst="ellipse">
@@ -10607,7 +10607,7 @@
         </p:blipFill>
         <p:spPr>
           <a:xfrm>
-            <a:off x="4958791" y="2188159"/>
+            <a:off x="5891479" y="2188159"/>
             <a:ext cx="378562" cy="378562"/>
           </a:xfrm>
           <a:prstGeom prst="rect">
@@ -10623,8 +10623,8 @@
         </p:nvSpPr>
         <p:spPr>
           <a:xfrm>
-            <a:off x="4370832" y="2926080"/>
-            <a:ext cx="1554480" cy="457200"/>
+            <a:off x="5138928" y="2926080"/>
+            <a:ext cx="1883664" cy="457200"/>
           </a:xfrm>
           <a:prstGeom prst="rect">
             <a:avLst/>
@@ -10659,8 +10659,8 @@
         </p:nvSpPr>
         <p:spPr>
           <a:xfrm>
-            <a:off x="4389120" y="3429000"/>
-            <a:ext cx="1517904" cy="1097280"/>
+            <a:off x="5184648" y="3429000"/>
+            <a:ext cx="1792224" cy="1097280"/>
           </a:xfrm>
           <a:prstGeom prst="rect">
             <a:avLst/>
@@ -10695,12 +10695,12 @@
         </p:nvSpPr>
         <p:spPr>
           <a:xfrm>
-            <a:off x="6144768" y="1737360"/>
-            <a:ext cx="1737360" cy="2926080"/>
+            <a:off x="7296912" y="1737360"/>
+            <a:ext cx="2066544" cy="2926080"/>
           </a:xfrm>
           <a:prstGeom prst="roundRect">
             <a:avLst>
-              <a:gd name="adj" fmla="val 6316"/>
+              <a:gd name="adj" fmla="val 5310"/>
             </a:avLst>
           </a:prstGeom>
           <a:solidFill>
@@ -10717,14 +10717,14 @@
         </p:nvSpPr>
         <p:spPr>
           <a:xfrm>
-            <a:off x="6601968" y="1965960"/>
+            <a:off x="7918704" y="1965960"/>
             <a:ext cx="822960" cy="822960"/>
           </a:xfrm>
           <a:prstGeom prst="ellipse">
             <a:avLst/>
           </a:prstGeom>
           <a:solidFill>
-            <a:schemeClr val="tx1"/>
+            <a:schemeClr val="accent1"/>
           </a:solidFill>
           <a:ln/>
         </p:spPr>
@@ -10745,7 +10745,7 @@
         </p:blipFill>
         <p:spPr>
           <a:xfrm>
-            <a:off x="6824167" y="2188159"/>
+            <a:off x="8140903" y="2188159"/>
             <a:ext cx="378562" cy="378562"/>
           </a:xfrm>
           <a:prstGeom prst="rect">
@@ -10761,8 +10761,8 @@
         </p:nvSpPr>
         <p:spPr>
           <a:xfrm>
-            <a:off x="6236208" y="2926080"/>
-            <a:ext cx="1554480" cy="457200"/>
+            <a:off x="7388352" y="2926080"/>
+            <a:ext cx="1883664" cy="457200"/>
           </a:xfrm>
           <a:prstGeom prst="rect">
             <a:avLst/>
@@ -10797,8 +10797,8 @@
         </p:nvSpPr>
         <p:spPr>
           <a:xfrm>
-            <a:off x="6254496" y="3429000"/>
-            <a:ext cx="1517904" cy="1097280"/>
+            <a:off x="7434072" y="3429000"/>
+            <a:ext cx="1792224" cy="1097280"/>
           </a:xfrm>
           <a:prstGeom prst="rect">
             <a:avLst/>
@@ -10833,12 +10833,12 @@
         </p:nvSpPr>
         <p:spPr>
           <a:xfrm>
-            <a:off x="8010144" y="1737360"/>
-            <a:ext cx="1737360" cy="2926080"/>
+            <a:off x="9546336" y="1737360"/>
+            <a:ext cx="2066544" cy="2926080"/>
           </a:xfrm>
           <a:prstGeom prst="roundRect">
             <a:avLst>
-              <a:gd name="adj" fmla="val 6316"/>
+              <a:gd name="adj" fmla="val 5310"/>
             </a:avLst>
           </a:prstGeom>
           <a:solidFill>
@@ -10849,27 +10849,27 @@
       </p:sp>
       <p:sp>
         <p:nvSpPr>
-          <p:cNvPr id="25" name="Círculo FaUserCheck"/>
+          <p:cNvPr id="25" name="Círculo FaLightbulb"/>
           <p:cNvSpPr/>
           <p:nvPr/>
         </p:nvSpPr>
         <p:spPr>
           <a:xfrm>
-            <a:off x="8467344" y="1965960"/>
+            <a:off x="10168128" y="1965960"/>
             <a:ext cx="822960" cy="822960"/>
           </a:xfrm>
           <a:prstGeom prst="ellipse">
             <a:avLst/>
           </a:prstGeom>
           <a:solidFill>
-            <a:schemeClr val="accent1"/>
+            <a:schemeClr val="tx1"/>
           </a:solidFill>
           <a:ln/>
         </p:spPr>
       </p:sp>
       <p:pic>
         <p:nvPicPr>
-          <p:cNvPr id="26" name="Image 4" descr="FaUserCheck">    </p:cNvPr>
+          <p:cNvPr id="26" name="Image 4" descr="FaLightbulb">    </p:cNvPr>
           <p:cNvPicPr>
             <a:picLocks noChangeAspect="1"/>
           </p:cNvPicPr>
@@ -10883,7 +10883,7 @@
         </p:blipFill>
         <p:spPr>
           <a:xfrm>
-            <a:off x="8689543" y="2188159"/>
+            <a:off x="10390327" y="2188159"/>
             <a:ext cx="378562" cy="378562"/>
           </a:xfrm>
           <a:prstGeom prst="rect">
@@ -10899,8 +10899,8 @@
         </p:nvSpPr>
         <p:spPr>
           <a:xfrm>
-            <a:off x="8101584" y="2926080"/>
-            <a:ext cx="1554480" cy="457200"/>
+            <a:off x="9637776" y="2926080"/>
+            <a:ext cx="1883664" cy="457200"/>
           </a:xfrm>
           <a:prstGeom prst="rect">
             <a:avLst/>
@@ -10921,7 +10921,7 @@
                   <a:schemeClr val="tx1"/>
                 </a:solidFill>
               </a:rPr>
-              <a:t>5 · Probar</a:t>
+              <a:t>5 · Acciones</a:t>
             </a:r>
             <a:endParaRPr lang="en-US" sz="1600" dirty="0"/>
           </a:p>
@@ -10935,8 +10935,8 @@
         </p:nvSpPr>
         <p:spPr>
           <a:xfrm>
-            <a:off x="8119872" y="3429000"/>
-            <a:ext cx="1517904" cy="1097280"/>
+            <a:off x="9683496" y="3429000"/>
+            <a:ext cx="1792224" cy="1097280"/>
           </a:xfrm>
           <a:prstGeom prst="rect">
             <a:avLst/>
@@ -10957,7 +10957,7 @@
                   <a:schemeClr val="tx2"/>
                 </a:solidFill>
               </a:rPr>
-              <a:t>Ejemplos y apoyo sugerido</a:t>
+              <a:t>Recomendaciones y uso responsable</a:t>
             </a:r>
             <a:endParaRPr lang="en-US" sz="1400" dirty="0"/>
           </a:p>
@@ -10965,39 +10965,19 @@
       </p:sp>
       <p:sp>
         <p:nvSpPr>
-          <p:cNvPr id="29" name="Tarjeta"/>
+          <p:cNvPr id="29" name="Comando"/>
           <p:cNvSpPr/>
           <p:nvPr/>
         </p:nvSpPr>
         <p:spPr>
           <a:xfrm>
-            <a:off x="9875520" y="1737360"/>
-            <a:ext cx="1737360" cy="2926080"/>
+            <a:off x="548640" y="4937760"/>
+            <a:ext cx="11064240" cy="1234440"/>
           </a:xfrm>
           <a:prstGeom prst="roundRect">
             <a:avLst>
-              <a:gd name="adj" fmla="val 6316"/>
+              <a:gd name="adj" fmla="val 8889"/>
             </a:avLst>
-          </a:prstGeom>
-          <a:solidFill>
-            <a:schemeClr val="bg2"/>
-          </a:solidFill>
-          <a:ln/>
-        </p:spPr>
-      </p:sp>
-      <p:sp>
-        <p:nvSpPr>
-          <p:cNvPr id="30" name="Círculo FaLightbulb"/>
-          <p:cNvSpPr/>
-          <p:nvPr/>
-        </p:nvSpPr>
-        <p:spPr>
-          <a:xfrm>
-            <a:off x="10332720" y="1965960"/>
-            <a:ext cx="822960" cy="822960"/>
-          </a:xfrm>
-          <a:prstGeom prst="ellipse">
-            <a:avLst/>
           </a:prstGeom>
           <a:solidFill>
             <a:schemeClr val="tx1"/>
@@ -11005,9 +10985,29 @@
           <a:ln/>
         </p:spPr>
       </p:sp>
+      <p:sp>
+        <p:nvSpPr>
+          <p:cNvPr id="30" name="Círculo FaLaptopCode"/>
+          <p:cNvSpPr/>
+          <p:nvPr/>
+        </p:nvSpPr>
+        <p:spPr>
+          <a:xfrm>
+            <a:off x="777240" y="5184648"/>
+            <a:ext cx="731520" cy="731520"/>
+          </a:xfrm>
+          <a:prstGeom prst="ellipse">
+            <a:avLst/>
+          </a:prstGeom>
+          <a:solidFill>
+            <a:schemeClr val="accent1"/>
+          </a:solidFill>
+          <a:ln/>
+        </p:spPr>
+      </p:sp>
       <p:pic>
         <p:nvPicPr>
-          <p:cNvPr id="31" name="Image 5" descr="FaLightbulb">    </p:cNvPr>
+          <p:cNvPr id="31" name="Image 5" descr="FaLaptopCode">    </p:cNvPr>
           <p:cNvPicPr>
             <a:picLocks noChangeAspect="1"/>
           </p:cNvPicPr>
@@ -11021,144 +11021,6 @@
         </p:blipFill>
         <p:spPr>
           <a:xfrm>
-            <a:off x="10554919" y="2188159"/>
-            <a:ext cx="378562" cy="378562"/>
-          </a:xfrm>
-          <a:prstGeom prst="rect">
-            <a:avLst/>
-          </a:prstGeom>
-        </p:spPr>
-      </p:pic>
-      <p:sp>
-        <p:nvSpPr>
-          <p:cNvPr id="32" name="Text 24"/>
-          <p:cNvSpPr txBox="1"/>
-          <p:nvPr/>
-        </p:nvSpPr>
-        <p:spPr>
-          <a:xfrm>
-            <a:off x="9966960" y="2926080"/>
-            <a:ext cx="1554480" cy="457200"/>
-          </a:xfrm>
-          <a:prstGeom prst="rect">
-            <a:avLst/>
-          </a:prstGeom>
-          <a:noFill/>
-          <a:ln/>
-        </p:spPr>
-        <p:txBody>
-          <a:bodyPr wrap="square" lIns="0" tIns="0" rIns="0" bIns="0" rtlCol="0" anchor="ctr"/>
-          <a:lstStyle/>
-          <a:p>
-            <a:pPr algn="ctr" indent="0" marL="0">
-              <a:buNone/>
-            </a:pPr>
-            <a:r>
-              <a:rPr lang="en-US" sz="1600" b="1" dirty="0">
-                <a:solidFill>
-                  <a:schemeClr val="tx1"/>
-                </a:solidFill>
-              </a:rPr>
-              <a:t>6 · Acciones</a:t>
-            </a:r>
-            <a:endParaRPr lang="en-US" sz="1600" dirty="0"/>
-          </a:p>
-        </p:txBody>
-      </p:sp>
-      <p:sp>
-        <p:nvSpPr>
-          <p:cNvPr id="33" name="Text 25"/>
-          <p:cNvSpPr txBox="1"/>
-          <p:nvPr/>
-        </p:nvSpPr>
-        <p:spPr>
-          <a:xfrm>
-            <a:off x="9985248" y="3429000"/>
-            <a:ext cx="1517904" cy="1097280"/>
-          </a:xfrm>
-          <a:prstGeom prst="rect">
-            <a:avLst/>
-          </a:prstGeom>
-          <a:noFill/>
-          <a:ln/>
-        </p:spPr>
-        <p:txBody>
-          <a:bodyPr wrap="square" lIns="0" tIns="0" rIns="0" bIns="0" rtlCol="0" anchor="t"/>
-          <a:lstStyle/>
-          <a:p>
-            <a:pPr algn="ctr" indent="0" marL="0">
-              <a:buNone/>
-            </a:pPr>
-            <a:r>
-              <a:rPr lang="en-US" sz="1400" dirty="0">
-                <a:solidFill>
-                  <a:schemeClr val="tx2"/>
-                </a:solidFill>
-              </a:rPr>
-              <a:t>Recomendaciones y uso responsable</a:t>
-            </a:r>
-            <a:endParaRPr lang="en-US" sz="1400" dirty="0"/>
-          </a:p>
-        </p:txBody>
-      </p:sp>
-      <p:sp>
-        <p:nvSpPr>
-          <p:cNvPr id="34" name="Comando"/>
-          <p:cNvSpPr/>
-          <p:nvPr/>
-        </p:nvSpPr>
-        <p:spPr>
-          <a:xfrm>
-            <a:off x="548640" y="4937760"/>
-            <a:ext cx="11064240" cy="1234440"/>
-          </a:xfrm>
-          <a:prstGeom prst="roundRect">
-            <a:avLst>
-              <a:gd name="adj" fmla="val 8889"/>
-            </a:avLst>
-          </a:prstGeom>
-          <a:solidFill>
-            <a:schemeClr val="tx1"/>
-          </a:solidFill>
-          <a:ln/>
-        </p:spPr>
-      </p:sp>
-      <p:sp>
-        <p:nvSpPr>
-          <p:cNvPr id="35" name="Círculo FaLaptopCode"/>
-          <p:cNvSpPr/>
-          <p:nvPr/>
-        </p:nvSpPr>
-        <p:spPr>
-          <a:xfrm>
-            <a:off x="777240" y="5184648"/>
-            <a:ext cx="731520" cy="731520"/>
-          </a:xfrm>
-          <a:prstGeom prst="ellipse">
-            <a:avLst/>
-          </a:prstGeom>
-          <a:solidFill>
-            <a:schemeClr val="accent1"/>
-          </a:solidFill>
-          <a:ln/>
-        </p:spPr>
-      </p:sp>
-      <p:pic>
-        <p:nvPicPr>
-          <p:cNvPr id="36" name="Image 6" descr="FaLaptopCode">    </p:cNvPr>
-          <p:cNvPicPr>
-            <a:picLocks noChangeAspect="1"/>
-          </p:cNvPicPr>
-          <p:nvPr/>
-        </p:nvPicPr>
-        <p:blipFill>
-          <a:blip r:embed="rId7"/>
-          <a:stretch>
-            <a:fillRect/>
-          </a:stretch>
-        </p:blipFill>
-        <p:spPr>
-          <a:xfrm>
             <a:off x="974750" y="5382158"/>
             <a:ext cx="336499" cy="336499"/>
           </a:xfrm>
@@ -11169,7 +11031,7 @@
       </p:pic>
       <p:sp>
         <p:nvSpPr>
-          <p:cNvPr id="37" name="Text 28"/>
+          <p:cNvPr id="32" name="Text 24"/>
           <p:cNvSpPr txBox="1"/>
           <p:nvPr/>
         </p:nvSpPr>
@@ -11214,7 +11076,7 @@
                   <a:schemeClr val="bg2"/>
                 </a:solidFill>
               </a:rPr>
-              <a:t>Cuenta el proyecto en 6 pasos y deja probar el modelo con estudiantes de ejemplo.</a:t>
+              <a:t>Cuenta el proyecto en 5 pasos y permite experimentar con el umbral del modelo.</a:t>
             </a:r>
             <a:endParaRPr lang="en-US" sz="2000" dirty="0"/>
           </a:p>

</xml_diff>